<commit_message>
update code and graphic
</commit_message>
<xml_diff>
--- a/docs/_static/image_sources/genai-serving-graph.pptx
+++ b/docs/_static/image_sources/genai-serving-graph.pptx
@@ -6,13 +6,12 @@
     <p:sldMasterId id="2147483864" r:id="rId2"/>
   </p:sldMasterIdLst>
   <p:sldIdLst>
-    <p:sldId id="256" r:id="rId3"/>
-    <p:sldId id="257" r:id="rId4"/>
+    <p:sldId id="257" r:id="rId3"/>
   </p:sldIdLst>
   <p:sldSz cx="12192000" cy="6858000"/>
   <p:notesSz cx="7102475" cy="9388475"/>
   <p:custDataLst>
-    <p:tags r:id="rId5"/>
+    <p:tags r:id="rId4"/>
   </p:custDataLst>
   <p:defaultTextStyle>
     <a:defPPr>
@@ -33709,136 +33708,6 @@
       </p:grpSpPr>
       <p:sp>
         <p:nvSpPr>
-          <p:cNvPr id="2" name="Picture Placeholder 1">
-            <a:extLst>
-              <a:ext uri="{FF2B5EF4-FFF2-40B4-BE49-F238E27FC236}">
-                <a16:creationId xmlns:a16="http://schemas.microsoft.com/office/drawing/2014/main" id="{B7EA905A-4996-6BAF-8762-57BAA0F632F6}"/>
-              </a:ext>
-            </a:extLst>
-          </p:cNvPr>
-          <p:cNvSpPr>
-            <a:spLocks noGrp="1"/>
-          </p:cNvSpPr>
-          <p:nvPr>
-            <p:ph type="pic" sz="quarter" idx="14"/>
-          </p:nvPr>
-        </p:nvSpPr>
-        <p:spPr/>
-        <p:txBody>
-          <a:bodyPr/>
-          <a:lstStyle/>
-          <a:p>
-            <a:endParaRPr lang="en-IL"/>
-          </a:p>
-        </p:txBody>
-      </p:sp>
-      <p:sp>
-        <p:nvSpPr>
-          <p:cNvPr id="3" name="Text Placeholder 2">
-            <a:extLst>
-              <a:ext uri="{FF2B5EF4-FFF2-40B4-BE49-F238E27FC236}">
-                <a16:creationId xmlns:a16="http://schemas.microsoft.com/office/drawing/2014/main" id="{D6760337-EE39-0A30-6A11-F4C742F11751}"/>
-              </a:ext>
-            </a:extLst>
-          </p:cNvPr>
-          <p:cNvSpPr>
-            <a:spLocks noGrp="1"/>
-          </p:cNvSpPr>
-          <p:nvPr>
-            <p:ph type="body" sz="quarter" idx="13"/>
-          </p:nvPr>
-        </p:nvSpPr>
-        <p:spPr/>
-        <p:txBody>
-          <a:bodyPr/>
-          <a:lstStyle/>
-          <a:p>
-            <a:endParaRPr lang="en-IL"/>
-          </a:p>
-        </p:txBody>
-      </p:sp>
-      <p:sp>
-        <p:nvSpPr>
-          <p:cNvPr id="4" name="Subtitle 3">
-            <a:extLst>
-              <a:ext uri="{FF2B5EF4-FFF2-40B4-BE49-F238E27FC236}">
-                <a16:creationId xmlns:a16="http://schemas.microsoft.com/office/drawing/2014/main" id="{BE9A63F8-BB23-28B1-CD89-9B1CB15810F5}"/>
-              </a:ext>
-            </a:extLst>
-          </p:cNvPr>
-          <p:cNvSpPr>
-            <a:spLocks noGrp="1"/>
-          </p:cNvSpPr>
-          <p:nvPr>
-            <p:ph type="subTitle" idx="1"/>
-          </p:nvPr>
-        </p:nvSpPr>
-        <p:spPr/>
-        <p:txBody>
-          <a:bodyPr/>
-          <a:lstStyle/>
-          <a:p>
-            <a:endParaRPr lang="en-IL"/>
-          </a:p>
-        </p:txBody>
-      </p:sp>
-      <p:sp>
-        <p:nvSpPr>
-          <p:cNvPr id="5" name="Title 4">
-            <a:extLst>
-              <a:ext uri="{FF2B5EF4-FFF2-40B4-BE49-F238E27FC236}">
-                <a16:creationId xmlns:a16="http://schemas.microsoft.com/office/drawing/2014/main" id="{A0E0BA5A-4150-304F-5961-47CE7C1DA89B}"/>
-              </a:ext>
-            </a:extLst>
-          </p:cNvPr>
-          <p:cNvSpPr>
-            <a:spLocks noGrp="1"/>
-          </p:cNvSpPr>
-          <p:nvPr>
-            <p:ph type="title"/>
-          </p:nvPr>
-        </p:nvSpPr>
-        <p:spPr/>
-        <p:txBody>
-          <a:bodyPr/>
-          <a:lstStyle/>
-          <a:p>
-            <a:endParaRPr lang="en-IL"/>
-          </a:p>
-        </p:txBody>
-      </p:sp>
-    </p:spTree>
-    <p:extLst>
-      <p:ext uri="{BB962C8B-B14F-4D97-AF65-F5344CB8AC3E}">
-        <p14:creationId xmlns:p14="http://schemas.microsoft.com/office/powerpoint/2010/main" val="493148220"/>
-      </p:ext>
-    </p:extLst>
-  </p:cSld>
-  <p:clrMapOvr>
-    <a:masterClrMapping/>
-  </p:clrMapOvr>
-</p:sld>
-</file>
-
-<file path=ppt/slides/slide2.xml><?xml version="1.0" encoding="utf-8"?>
-<p:sld xmlns:a="http://schemas.openxmlformats.org/drawingml/2006/main" xmlns:r="http://schemas.openxmlformats.org/officeDocument/2006/relationships" xmlns:p="http://schemas.openxmlformats.org/presentationml/2006/main">
-  <p:cSld>
-    <p:spTree>
-      <p:nvGrpSpPr>
-        <p:cNvPr id="1" name=""/>
-        <p:cNvGrpSpPr/>
-        <p:nvPr/>
-      </p:nvGrpSpPr>
-      <p:grpSpPr>
-        <a:xfrm>
-          <a:off x="0" y="0"/>
-          <a:ext cx="0" cy="0"/>
-          <a:chOff x="0" y="0"/>
-          <a:chExt cx="0" cy="0"/>
-        </a:xfrm>
-      </p:grpSpPr>
-      <p:sp>
-        <p:nvSpPr>
           <p:cNvPr id="3" name="Oval 2">
             <a:extLst>
               <a:ext uri="{FF2B5EF4-FFF2-40B4-BE49-F238E27FC236}">
@@ -33851,7 +33720,7 @@
         </p:nvSpPr>
         <p:spPr>
           <a:xfrm>
-            <a:off x="4670230" y="240481"/>
+            <a:off x="4936049" y="240481"/>
             <a:ext cx="1702676" cy="842407"/>
           </a:xfrm>
           <a:prstGeom prst="ellipse">
@@ -33920,7 +33789,7 @@
         </p:nvSpPr>
         <p:spPr>
           <a:xfrm>
-            <a:off x="5458506" y="546859"/>
+            <a:off x="5724325" y="546859"/>
             <a:ext cx="126124" cy="45719"/>
           </a:xfrm>
           <a:prstGeom prst="rect">
@@ -33967,7 +33836,7 @@
         </p:nvSpPr>
         <p:spPr>
           <a:xfrm>
-            <a:off x="4389119" y="1519312"/>
+            <a:off x="4644305" y="1519312"/>
             <a:ext cx="2264898" cy="829993"/>
           </a:xfrm>
           <a:prstGeom prst="rect">
@@ -34035,9 +33904,9 @@
           <p:nvPr/>
         </p:nvSpPr>
         <p:spPr>
-          <a:xfrm>
-            <a:off x="5521568" y="1828801"/>
-            <a:ext cx="0" cy="0"/>
+          <a:xfrm flipH="1">
+            <a:off x="5731035" y="1658673"/>
+            <a:ext cx="45719" cy="84080"/>
           </a:xfrm>
           <a:prstGeom prst="rect">
             <a:avLst/>
@@ -34064,7 +33933,14 @@
             </a:pPr>
             <a:r>
               <a:rPr lang="en-IL" sz="1600" dirty="0"/>
-              <a:t>Classifier</a:t>
+              <a:t>Classifier template:</a:t>
+            </a:r>
+            <a:br>
+              <a:rPr lang="en-IL" sz="1600" dirty="0"/>
+            </a:br>
+            <a:r>
+              <a:rPr lang="en-IL" sz="1600" dirty="0"/>
+              <a:t>understand intention</a:t>
             </a:r>
           </a:p>
         </p:txBody>
@@ -34083,7 +33959,7 @@
         </p:nvSpPr>
         <p:spPr>
           <a:xfrm>
-            <a:off x="4121834" y="3094893"/>
+            <a:off x="4387653" y="3094893"/>
             <a:ext cx="2771332" cy="1950155"/>
           </a:xfrm>
           <a:prstGeom prst="diamond">
@@ -34152,7 +34028,7 @@
         </p:nvSpPr>
         <p:spPr>
           <a:xfrm>
-            <a:off x="5460123" y="3896750"/>
+            <a:off x="5725942" y="3896750"/>
             <a:ext cx="94755" cy="182881"/>
           </a:xfrm>
           <a:prstGeom prst="rect">
@@ -34440,7 +34316,7 @@
             </a:br>
             <a:r>
               <a:rPr lang="en-IL" sz="1600" dirty="0"/>
-              <a:t>description of issue</a:t>
+              <a:t>description of problem</a:t>
             </a:r>
           </a:p>
         </p:txBody>
@@ -34610,7 +34486,7 @@
             </a:br>
             <a:r>
               <a:rPr lang="en-IL" sz="1600" dirty="0"/>
-              <a:t>for issue</a:t>
+              <a:t>for problem</a:t>
             </a:r>
           </a:p>
         </p:txBody>
@@ -34754,7 +34630,7 @@
         </p:nvCxnSpPr>
         <p:spPr>
           <a:xfrm>
-            <a:off x="5521568" y="1082888"/>
+            <a:off x="5787387" y="1082888"/>
             <a:ext cx="0" cy="436424"/>
           </a:xfrm>
           <a:prstGeom prst="straightConnector1">
@@ -34800,7 +34676,7 @@
         </p:nvCxnSpPr>
         <p:spPr>
           <a:xfrm>
-            <a:off x="5497880" y="2349305"/>
+            <a:off x="5763699" y="2349305"/>
             <a:ext cx="9620" cy="745588"/>
           </a:xfrm>
           <a:prstGeom prst="straightConnector1">
@@ -34847,8 +34723,8 @@
         </p:nvCxnSpPr>
         <p:spPr>
           <a:xfrm flipV="1">
-            <a:off x="6893166" y="4065565"/>
-            <a:ext cx="2600181" cy="4406"/>
+            <a:off x="7158985" y="4065565"/>
+            <a:ext cx="2334362" cy="4406"/>
           </a:xfrm>
           <a:prstGeom prst="straightConnector1">
             <a:avLst/>
@@ -34895,7 +34771,7 @@
         <p:spPr>
           <a:xfrm flipH="1" flipV="1">
             <a:off x="2541557" y="4069082"/>
-            <a:ext cx="1580277" cy="889"/>
+            <a:ext cx="1846096" cy="889"/>
           </a:xfrm>
           <a:prstGeom prst="straightConnector1">
             <a:avLst/>
@@ -35028,7 +34904,7 @@
         </p:nvSpPr>
         <p:spPr>
           <a:xfrm>
-            <a:off x="6667133" y="3479542"/>
+            <a:off x="6815989" y="3459187"/>
             <a:ext cx="2820886" cy="215444"/>
           </a:xfrm>
           <a:prstGeom prst="rect">
@@ -35257,8 +35133,8 @@
         </p:nvSpPr>
         <p:spPr>
           <a:xfrm>
-            <a:off x="2710066" y="3388489"/>
-            <a:ext cx="1411768" cy="430887"/>
+            <a:off x="2710066" y="3399122"/>
+            <a:ext cx="1944872" cy="215444"/>
           </a:xfrm>
           <a:prstGeom prst="rect">
             <a:avLst/>
@@ -35422,14 +35298,7 @@
           <a:p>
             <a:r>
               <a:rPr lang="en-US" sz="1400" dirty="0"/>
-              <a:t>Customer has a </a:t>
-            </a:r>
-            <a:br>
-              <a:rPr lang="en-US" sz="1400" dirty="0"/>
-            </a:br>
-            <a:r>
-              <a:rPr lang="en-US" sz="1400" dirty="0"/>
-              <a:t>problem</a:t>
+              <a:t>Customer has a problem</a:t>
             </a:r>
             <a:endParaRPr lang="en-IL" sz="1400" dirty="0"/>
           </a:p>
@@ -35451,6 +35320,7 @@
 <file path=ppt/tags/tag1.xml><?xml version="1.0" encoding="utf-8"?>
 <p:tagLst xmlns:a="http://schemas.openxmlformats.org/drawingml/2006/main" xmlns:r="http://schemas.openxmlformats.org/officeDocument/2006/relationships" xmlns:p="http://schemas.openxmlformats.org/presentationml/2006/main">
   <p:tag name="NEWVI" val="true"/>
+  <p:tag name="LINKEDPICTURESLINKREMOVED" val="True"/>
 </p:tagLst>
 </file>
 

</xml_diff>